<commit_message>
docs(deck): rewrite day-by-day plan to match in-progress reality
Previous schedule started with "pipeline scaffold" on Day 1, which
contradicted the new framing where the semantic schema and FK graph
are themselves still in progress. Reordered so the first two days
explicitly finish those two layers, then Mon lights up the end-to-end
pipeline, Tue lands validation + tier-3/4 entity resolution, Wed lands
charts + Settings UI, Thu lands eval dashboard + cluster manager + the
two flagged security fixes, Fri is demo prep + release.

Each day now names a concrete milestone in language consistent with
what the rest of the deck calls "in progress" — full Ed-Fi coverage
on the semantic blobs, weighted graph + Steiner solvers, four-tier
entity resolver, validator+repair, charts+descriptions, eval+UI, then
hardening and demo.

Co-Authored-By: Claude Opus 4.7 (1M context) <noreply@anthropic.com>
</commit_message>
<xml_diff>
--- a/docs/architecture_deck.pptx
+++ b/docs/architecture_deck.pptx
@@ -939,7 +939,7 @@
           <a:lstStyle/>
           <a:p>
             <a:r>
-              <a:t>Front-loaded the pipeline because it unblocks UI and eval. Auto-grouping is a spike — if it doesn't tune well, we ship per-domain routing for v0.8 and revisit.</a:t>
+              <a:t>Reordered to match what's actually unfinished: the first two days finish the semantic and graph layers (the deck calls those 'in progress' for a reason), Mon lights up the end-to-end pipeline, Tue–Wed land validation + UI, Thu hardens, Fri is demo. No buffer — risks slide flags fallbacks if any one day slips.</a:t>
             </a:r>
           </a:p>
         </p:txBody>
@@ -8332,7 +8332,7 @@
                 </a:solidFill>
                 <a:latin typeface="Helvetica Neue"/>
               </a:rPr>
-              <a:t>Pipeline scaffold + auto-grouping spike</a:t>
+              <a:t>Semantic schema — finish per-table profiles + tune routing</a:t>
             </a:r>
           </a:p>
         </p:txBody>
@@ -8367,7 +8367,7 @@
                 </a:solidFill>
                 <a:latin typeface="Helvetica Neue"/>
               </a:rPr>
-              <a:t>•  Wire question → semantic search → graph join into a single orchestrator</a:t>
+              <a:t>•  Build per-table semantic blobs across the full 1,048-table model (today only the demo DB is covered)</a:t>
             </a:r>
           </a:p>
         </p:txBody>
@@ -8402,7 +8402,7 @@
                 </a:solidFill>
                 <a:latin typeface="Helvetica Neue"/>
               </a:rPr>
-              <a:t>•  Spike Leiden auto-grouping inside oversize domains for sharper routing</a:t>
+              <a:t>•  Tune cluster + table routing thresholds; lock the top-3 retrieval mix</a:t>
             </a:r>
           </a:p>
         </p:txBody>
@@ -8437,7 +8437,7 @@
                 </a:solidFill>
                 <a:latin typeface="Helvetica Neue"/>
               </a:rPr>
-              <a:t>•  Verify the platform handles real-world databases that have non-Ed-Fi tables</a:t>
+              <a:t>•  Wire entity-resolver tiers 1–2 (Bloom + fuzzy) end-to-end</a:t>
             </a:r>
           </a:p>
         </p:txBody>
@@ -8507,7 +8507,7 @@
                 </a:solidFill>
                 <a:latin typeface="Helvetica Neue"/>
               </a:rPr>
-              <a:t>Pipeline land + retrieval polish</a:t>
+              <a:t>Foreign-key graph — finish weights + Steiner integration</a:t>
             </a:r>
           </a:p>
         </p:txBody>
@@ -8542,7 +8542,7 @@
                 </a:solidFill>
                 <a:latin typeface="Helvetica Neue"/>
               </a:rPr>
-              <a:t>•  Productionize the orchestrator with structured logs at every stage</a:t>
+              <a:t>•  Apply weighted edges across the full Ed-Fi graph; verify &lt;10 MB load + &lt;100 ms startup</a:t>
             </a:r>
           </a:p>
         </p:txBody>
@@ -8577,7 +8577,7 @@
                 </a:solidFill>
                 <a:latin typeface="Helvetica Neue"/>
               </a:rPr>
-              <a:t>•  Add proven-query retrieval (top-3 examples passed to the SQL generator)</a:t>
+              <a:t>•  Land bidirectional Dijkstra (k=2) + KMB Steiner (k=3–8) behind a single solver entrypoint</a:t>
             </a:r>
           </a:p>
         </p:txBody>
@@ -8612,7 +8612,7 @@
                 </a:solidFill>
                 <a:latin typeface="Helvetica Neue"/>
               </a:rPr>
-              <a:t>•  First end-to-end NL → SQL → rows on the demo SQLite database</a:t>
+              <a:t>•  Integrate with the new unknown-table reflection path so non-Ed-Fi tables join cleanly</a:t>
             </a:r>
           </a:p>
         </p:txBody>
@@ -8682,7 +8682,7 @@
                 </a:solidFill>
                 <a:latin typeface="Helvetica Neue"/>
               </a:rPr>
-              <a:t>Validation &amp; repair loop</a:t>
+              <a:t>Question → SQL pipeline — first end-to-end run</a:t>
             </a:r>
           </a:p>
         </p:txBody>
@@ -8717,7 +8717,7 @@
                 </a:solidFill>
                 <a:latin typeface="Helvetica Neue"/>
               </a:rPr>
-              <a:t>•  Parse-check, plan-check, and dry-execute every generated query</a:t>
+              <a:t>•  Wire question → semantic routing → graph join → SQL generator into one orchestrator</a:t>
             </a:r>
           </a:p>
         </p:txBody>
@@ -8752,7 +8752,7 @@
                 </a:solidFill>
                 <a:latin typeface="Helvetica Neue"/>
               </a:rPr>
-              <a:t>•  Three-attempt repair loop for typical failure modes</a:t>
+              <a:t>•  Add proven-query retrieval (top-3 examples passed to the SQL generator)</a:t>
             </a:r>
           </a:p>
         </p:txBody>
@@ -8787,7 +8787,7 @@
                 </a:solidFill>
                 <a:latin typeface="Helvetica Neue"/>
               </a:rPr>
-              <a:t>•  Expand the gold-query test suite to 50 questions; run nightly</a:t>
+              <a:t>•  First green NL → SQL → rows trace on the demo SQLite DB; structured logs at every stage</a:t>
             </a:r>
           </a:p>
         </p:txBody>
@@ -8857,7 +8857,7 @@
                 </a:solidFill>
                 <a:latin typeface="Helvetica Neue"/>
               </a:rPr>
-              <a:t>Charts, descriptions, and Settings UI</a:t>
+              <a:t>Validation &amp; repair loop + Tier-3/4 entity resolution</a:t>
             </a:r>
           </a:p>
         </p:txBody>
@@ -8892,7 +8892,7 @@
                 </a:solidFill>
                 <a:latin typeface="Helvetica Neue"/>
               </a:rPr>
-              <a:t>•  Auto-pick chart type from result shape (Vega-Lite spec generation)</a:t>
+              <a:t>•  Parse-check, plan-check, and dry-execute every generated query</a:t>
             </a:r>
           </a:p>
         </p:txBody>
@@ -8927,7 +8927,7 @@
                 </a:solidFill>
                 <a:latin typeface="Helvetica Neue"/>
               </a:rPr>
-              <a:t>•  Plain-English answer summary running in parallel with chart render</a:t>
+              <a:t>•  Three-attempt repair loop for typical failure modes</a:t>
             </a:r>
           </a:p>
         </p:txBody>
@@ -8962,7 +8962,7 @@
                 </a:solidFill>
                 <a:latin typeface="Helvetica Neue"/>
               </a:rPr>
-              <a:t>•  Settings page editable end-to-end — pick database, LLM, embedding via UI</a:t>
+              <a:t>•  Land semantic + LLM disambiguation tiers; expand gold-query suite to 50 questions</a:t>
             </a:r>
           </a:p>
         </p:txBody>
@@ -9032,7 +9032,7 @@
                 </a:solidFill>
                 <a:latin typeface="Helvetica Neue"/>
               </a:rPr>
-              <a:t>Eval dashboard + cluster manager</a:t>
+              <a:t>Charts, descriptions, Settings UI editable end-to-end</a:t>
             </a:r>
           </a:p>
         </p:txBody>
@@ -9067,7 +9067,7 @@
                 </a:solidFill>
                 <a:latin typeface="Helvetica Neue"/>
               </a:rPr>
-              <a:t>•  Eval Dashboard page: per-build metrics, regression alerts</a:t>
+              <a:t>•  Auto-pick chart type from result shape (Vega-Lite spec generation)</a:t>
             </a:r>
           </a:p>
         </p:txBody>
@@ -9102,7 +9102,7 @@
                 </a:solidFill>
                 <a:latin typeface="Helvetica Neue"/>
               </a:rPr>
-              <a:t>•  Cluster Manager page: drag tables between groups, trigger rebuild</a:t>
+              <a:t>•  Plain-English answer summary running in parallel with chart render</a:t>
             </a:r>
           </a:p>
         </p:txBody>
@@ -9137,7 +9137,7 @@
                 </a:solidFill>
                 <a:latin typeface="Helvetica Neue"/>
               </a:rPr>
-              <a:t>•  Operator runbook + provider-swap guide</a:t>
+              <a:t>•  Settings page fully editable — pick database, LLM, embedding via UI; ship onboarding flow</a:t>
             </a:r>
           </a:p>
         </p:txBody>
@@ -9207,7 +9207,7 @@
                 </a:solidFill>
                 <a:latin typeface="Helvetica Neue"/>
               </a:rPr>
-              <a:t>Hardening + multi-provider polish</a:t>
+              <a:t>Eval dashboard + cluster manager UI + hardening</a:t>
             </a:r>
           </a:p>
         </p:txBody>
@@ -9242,7 +9242,7 @@
                 </a:solidFill>
                 <a:latin typeface="Helvetica Neue"/>
               </a:rPr>
-              <a:t>•  Multi-provider matrix tested across all combinations</a:t>
+              <a:t>•  Eval Dashboard page: per-build metrics, regression alerts</a:t>
             </a:r>
           </a:p>
         </p:txBody>
@@ -9277,7 +9277,7 @@
                 </a:solidFill>
                 <a:latin typeface="Helvetica Neue"/>
               </a:rPr>
-              <a:t>•  Performance pass — caching, observability dashboards</a:t>
+              <a:t>•  Cluster Manager page: drag tables between groups, trigger rebuild from UI</a:t>
             </a:r>
           </a:p>
         </p:txBody>
@@ -9312,7 +9312,7 @@
                 </a:solidFill>
                 <a:latin typeface="Helvetica Neue"/>
               </a:rPr>
-              <a:t>•  Two security fixes flagged in earlier review</a:t>
+              <a:t>•  Multi-provider matrix; observability dashboards; two security fixes flagged in review</a:t>
             </a:r>
           </a:p>
         </p:txBody>
@@ -9417,7 +9417,7 @@
                 </a:solidFill>
                 <a:latin typeface="Helvetica Neue"/>
               </a:rPr>
-              <a:t>•  End-to-end run on a clean Mac and Windows machine</a:t>
+              <a:t>•  End-to-end dry-run on a clean Mac and Windows machine</a:t>
             </a:r>
           </a:p>
         </p:txBody>
@@ -9452,7 +9452,7 @@
                 </a:solidFill>
                 <a:latin typeface="Helvetica Neue"/>
               </a:rPr>
-              <a:t>•  Recorded demo: connect database → ask question → see chart + summary</a:t>
+              <a:t>•  Recorded demo: connect DB → ask question → see SQL + rows + chart + summary</a:t>
             </a:r>
           </a:p>
         </p:txBody>
@@ -9487,7 +9487,7 @@
                 </a:solidFill>
                 <a:latin typeface="Helvetica Neue"/>
               </a:rPr>
-              <a:t>•  v0.8 release tag pushed; final docs</a:t>
+              <a:t>•  v0.8 release tag + operator runbook + provider-swap guide</a:t>
             </a:r>
           </a:p>
         </p:txBody>

</xml_diff>

<commit_message>
docs(deck): drop May 1 (holiday) from the day-by-day plan
May 1 is a public holiday — fold the FK-graph milestone into Mon May 4
(graph + first end-to-end pipeline run share a day). Plan is now 6
working days: Apr 30, May 4-8.

Updated every "7-day" / "7 working days" reference across the deck
(slide subtitle, status snapshot, system-map legend, section dividers)
to "6 working days · May 1 holiday + weekends excluded".

Co-Authored-By: Claude Opus 4.7 (1M context) <noreply@anthropic.com>
</commit_message>
<xml_diff>
--- a/docs/architecture_deck.pptx
+++ b/docs/architecture_deck.pptx
@@ -659,7 +659,7 @@
           <a:lstStyle/>
           <a:p>
             <a:r>
-              <a:t>If semantic gives us 'these 5 tables', graph tells us 'this is the cheapest, most natural way to connect them'. Without it, even an LLM that knows Ed-Fi well would burn time guessing join paths. Today: shortest-path + Steiner-tree scaffolding running on the demo DB. Next 7 days: tune weights on the full Ed-Fi model and verify behavior on the unknown-table reflection path.</a:t>
+              <a:t>If semantic gives us 'these 5 tables', graph tells us 'this is the cheapest, most natural way to connect them'. Without it, even an LLM that knows Ed-Fi well would burn time guessing join paths. Today: shortest-path + Steiner-tree scaffolding running on the demo DB. Next 6 working days: tune weights on the full Ed-Fimodel and verify behavior on the unknown-table reflection path.</a:t>
             </a:r>
           </a:p>
         </p:txBody>
@@ -1219,7 +1219,7 @@
           <a:lstStyle/>
           <a:p>
             <a:r>
-              <a:t>This single slide is the headline. Cluster Creation is the only workstream that's functionally complete; the semantic schema and foreign-key graph have scaffolding but are still being tuned, and everything else is integration work in flight. That's why the 7-working-day plan is intentionally aggressive but bounded.</a:t>
+              <a:t>This single slide is the headline. Cluster Creation is the only workstream that's functionally complete; the semantic schema and foreign-key graph have scaffolding but are still being tuned, and everything else is integration work in flight. That's why the 6-working-day plan is intentionally aggressive but bounded.</a:t>
             </a:r>
           </a:p>
         </p:txBody>
@@ -1499,7 +1499,7 @@
           <a:lstStyle/>
           <a:p>
             <a:r>
-              <a:t>If we just gave the LLM 1,048 tables and asked it to pick, accuracy would collapse and cost would explode. The semantic layer is the search index that fixes that. Today: per-table profiles + embeddings work end-to-end on the demo DB; next 7 days: tune coverage on the full 1,048-table model and harden the routing thresholds.</a:t>
+              <a:t>If we just gave the LLM 1,048 tables and asked it to pick, accuracy would collapse and cost would explode. The semantic layer is the search index that fixes that. Today: per-table profiles + embeddings work end-to-end on the demo DB; next 6 working days: tune coverage on the full 1,048-table model and harden the routing thresholds.</a:t>
             </a:r>
           </a:p>
         </p:txBody>
@@ -7558,7 +7558,7 @@
                 </a:solidFill>
                 <a:latin typeface="Helvetica Neue"/>
               </a:rPr>
-              <a:t>7 working days · Apr 30 → Fri May 8 · weekend-free</a:t>
+              <a:t>6 working days · Apr 30 → Fri May 8 · May 1 holiday + weekends excluded</a:t>
             </a:r>
           </a:p>
         </p:txBody>
@@ -8216,7 +8216,7 @@
                 </a:solidFill>
                 <a:latin typeface="Helvetica Neue"/>
               </a:rPr>
-              <a:t>Apr 30 → Fri May 8 · 7 working days · weekends excluded</a:t>
+              <a:t>Apr 30 → Fri May 8 · 6 working days · May 1 holiday + weekends excluded</a:t>
             </a:r>
           </a:p>
         </p:txBody>
@@ -8472,7 +8472,7 @@
                 </a:solidFill>
                 <a:latin typeface="Helvetica Neue"/>
               </a:rPr>
-              <a:t>Fri May 1</a:t>
+              <a:t>Mon May 4</a:t>
             </a:r>
           </a:p>
         </p:txBody>
@@ -8507,7 +8507,7 @@
                 </a:solidFill>
                 <a:latin typeface="Helvetica Neue"/>
               </a:rPr>
-              <a:t>Foreign-key graph — finish weights + Steiner integration</a:t>
+              <a:t>Foreign-key graph + first end-to-end pipeline run</a:t>
             </a:r>
           </a:p>
         </p:txBody>
@@ -8612,7 +8612,7 @@
                 </a:solidFill>
                 <a:latin typeface="Helvetica Neue"/>
               </a:rPr>
-              <a:t>•  Integrate with the new unknown-table reflection path so non-Ed-Fi tables join cleanly</a:t>
+              <a:t>•  Wire question → semantic routing → graph join → SQL generator into one orchestrator</a:t>
             </a:r>
           </a:p>
         </p:txBody>
@@ -8625,7 +8625,42 @@
         </p:nvSpPr>
         <p:spPr>
           <a:xfrm>
-            <a:off x="640080" y="3300983"/>
+            <a:off x="2286000" y="3218687"/>
+            <a:ext cx="9418320" cy="228600"/>
+          </a:xfrm>
+          <a:prstGeom prst="rect">
+            <a:avLst/>
+          </a:prstGeom>
+          <a:noFill/>
+        </p:spPr>
+        <p:txBody>
+          <a:bodyPr wrap="square" lIns="45720" rIns="45720">
+            <a:spAutoFit/>
+          </a:bodyPr>
+          <a:lstStyle/>
+          <a:p>
+            <a:pPr algn="l"/>
+            <a:r>
+              <a:rPr sz="1000" b="0">
+                <a:solidFill>
+                  <a:srgbClr val="8A95A5"/>
+                </a:solidFill>
+                <a:latin typeface="Helvetica Neue"/>
+              </a:rPr>
+              <a:t>•  First green NL → SQL → rows trace on the demo SQLite DB</a:t>
+            </a:r>
+          </a:p>
+        </p:txBody>
+      </p:sp>
+      <p:sp>
+        <p:nvSpPr>
+          <p:cNvPr id="16" name="TextBox 15"/>
+          <p:cNvSpPr txBox="1"/>
+          <p:nvPr/>
+        </p:nvSpPr>
+        <p:spPr>
+          <a:xfrm>
+            <a:off x="640080" y="3493007"/>
             <a:ext cx="1554480" cy="274320"/>
           </a:xfrm>
           <a:prstGeom prst="rect">
@@ -8647,20 +8682,20 @@
                 </a:solidFill>
                 <a:latin typeface="Helvetica Neue"/>
               </a:rPr>
-              <a:t>Mon May 4</a:t>
-            </a:r>
-          </a:p>
-        </p:txBody>
-      </p:sp>
-      <p:sp>
-        <p:nvSpPr>
-          <p:cNvPr id="16" name="TextBox 15"/>
-          <p:cNvSpPr txBox="1"/>
-          <p:nvPr/>
-        </p:nvSpPr>
-        <p:spPr>
-          <a:xfrm>
-            <a:off x="2286000" y="3300983"/>
+              <a:t>Tue May 5</a:t>
+            </a:r>
+          </a:p>
+        </p:txBody>
+      </p:sp>
+      <p:sp>
+        <p:nvSpPr>
+          <p:cNvPr id="17" name="TextBox 16"/>
+          <p:cNvSpPr txBox="1"/>
+          <p:nvPr/>
+        </p:nvSpPr>
+        <p:spPr>
+          <a:xfrm>
+            <a:off x="2286000" y="3493007"/>
             <a:ext cx="9418320" cy="274320"/>
           </a:xfrm>
           <a:prstGeom prst="rect">
@@ -8682,42 +8717,7 @@
                 </a:solidFill>
                 <a:latin typeface="Helvetica Neue"/>
               </a:rPr>
-              <a:t>Question → SQL pipeline — first end-to-end run</a:t>
-            </a:r>
-          </a:p>
-        </p:txBody>
-      </p:sp>
-      <p:sp>
-        <p:nvSpPr>
-          <p:cNvPr id="17" name="TextBox 16"/>
-          <p:cNvSpPr txBox="1"/>
-          <p:nvPr/>
-        </p:nvSpPr>
-        <p:spPr>
-          <a:xfrm>
-            <a:off x="2286000" y="3493007"/>
-            <a:ext cx="9418320" cy="228600"/>
-          </a:xfrm>
-          <a:prstGeom prst="rect">
-            <a:avLst/>
-          </a:prstGeom>
-          <a:noFill/>
-        </p:spPr>
-        <p:txBody>
-          <a:bodyPr wrap="square" lIns="45720" rIns="45720">
-            <a:spAutoFit/>
-          </a:bodyPr>
-          <a:lstStyle/>
-          <a:p>
-            <a:pPr algn="l"/>
-            <a:r>
-              <a:rPr sz="1000" b="0">
-                <a:solidFill>
-                  <a:srgbClr val="8A95A5"/>
-                </a:solidFill>
-                <a:latin typeface="Helvetica Neue"/>
-              </a:rPr>
-              <a:t>•  Wire question → semantic routing → graph join → SQL generator into one orchestrator</a:t>
+              <a:t>Validation &amp; repair loop + Tier-3/4 entity resolution</a:t>
             </a:r>
           </a:p>
         </p:txBody>
@@ -8752,7 +8752,7 @@
                 </a:solidFill>
                 <a:latin typeface="Helvetica Neue"/>
               </a:rPr>
-              <a:t>•  Add proven-query retrieval (top-3 examples passed to the SQL generator)</a:t>
+              <a:t>•  Parse-check, plan-check, and dry-execute every generated query</a:t>
             </a:r>
           </a:p>
         </p:txBody>
@@ -8787,7 +8787,7 @@
                 </a:solidFill>
                 <a:latin typeface="Helvetica Neue"/>
               </a:rPr>
-              <a:t>•  First green NL → SQL → rows trace on the demo SQLite DB; structured logs at every stage</a:t>
+              <a:t>•  Three-attempt repair loop for typical failure modes</a:t>
             </a:r>
           </a:p>
         </p:txBody>
@@ -8800,7 +8800,42 @@
         </p:nvSpPr>
         <p:spPr>
           <a:xfrm>
-            <a:off x="640080" y="4151375"/>
+            <a:off x="2286000" y="4069079"/>
+            <a:ext cx="9418320" cy="228600"/>
+          </a:xfrm>
+          <a:prstGeom prst="rect">
+            <a:avLst/>
+          </a:prstGeom>
+          <a:noFill/>
+        </p:spPr>
+        <p:txBody>
+          <a:bodyPr wrap="square" lIns="45720" rIns="45720">
+            <a:spAutoFit/>
+          </a:bodyPr>
+          <a:lstStyle/>
+          <a:p>
+            <a:pPr algn="l"/>
+            <a:r>
+              <a:rPr sz="1000" b="0">
+                <a:solidFill>
+                  <a:srgbClr val="8A95A5"/>
+                </a:solidFill>
+                <a:latin typeface="Helvetica Neue"/>
+              </a:rPr>
+              <a:t>•  Land semantic + LLM disambiguation tiers; expand gold-query suite to 50 questions</a:t>
+            </a:r>
+          </a:p>
+        </p:txBody>
+      </p:sp>
+      <p:sp>
+        <p:nvSpPr>
+          <p:cNvPr id="21" name="TextBox 20"/>
+          <p:cNvSpPr txBox="1"/>
+          <p:nvPr/>
+        </p:nvSpPr>
+        <p:spPr>
+          <a:xfrm>
+            <a:off x="640080" y="4343399"/>
             <a:ext cx="1554480" cy="274320"/>
           </a:xfrm>
           <a:prstGeom prst="rect">
@@ -8822,20 +8857,20 @@
                 </a:solidFill>
                 <a:latin typeface="Helvetica Neue"/>
               </a:rPr>
-              <a:t>Tue May 5</a:t>
-            </a:r>
-          </a:p>
-        </p:txBody>
-      </p:sp>
-      <p:sp>
-        <p:nvSpPr>
-          <p:cNvPr id="21" name="TextBox 20"/>
-          <p:cNvSpPr txBox="1"/>
-          <p:nvPr/>
-        </p:nvSpPr>
-        <p:spPr>
-          <a:xfrm>
-            <a:off x="2286000" y="4151375"/>
+              <a:t>Wed May 6</a:t>
+            </a:r>
+          </a:p>
+        </p:txBody>
+      </p:sp>
+      <p:sp>
+        <p:nvSpPr>
+          <p:cNvPr id="22" name="TextBox 21"/>
+          <p:cNvSpPr txBox="1"/>
+          <p:nvPr/>
+        </p:nvSpPr>
+        <p:spPr>
+          <a:xfrm>
+            <a:off x="2286000" y="4343399"/>
             <a:ext cx="9418320" cy="274320"/>
           </a:xfrm>
           <a:prstGeom prst="rect">
@@ -8857,42 +8892,7 @@
                 </a:solidFill>
                 <a:latin typeface="Helvetica Neue"/>
               </a:rPr>
-              <a:t>Validation &amp; repair loop + Tier-3/4 entity resolution</a:t>
-            </a:r>
-          </a:p>
-        </p:txBody>
-      </p:sp>
-      <p:sp>
-        <p:nvSpPr>
-          <p:cNvPr id="22" name="TextBox 21"/>
-          <p:cNvSpPr txBox="1"/>
-          <p:nvPr/>
-        </p:nvSpPr>
-        <p:spPr>
-          <a:xfrm>
-            <a:off x="2286000" y="4343399"/>
-            <a:ext cx="9418320" cy="228600"/>
-          </a:xfrm>
-          <a:prstGeom prst="rect">
-            <a:avLst/>
-          </a:prstGeom>
-          <a:noFill/>
-        </p:spPr>
-        <p:txBody>
-          <a:bodyPr wrap="square" lIns="45720" rIns="45720">
-            <a:spAutoFit/>
-          </a:bodyPr>
-          <a:lstStyle/>
-          <a:p>
-            <a:pPr algn="l"/>
-            <a:r>
-              <a:rPr sz="1000" b="0">
-                <a:solidFill>
-                  <a:srgbClr val="8A95A5"/>
-                </a:solidFill>
-                <a:latin typeface="Helvetica Neue"/>
-              </a:rPr>
-              <a:t>•  Parse-check, plan-check, and dry-execute every generated query</a:t>
+              <a:t>Charts, descriptions, Settings UI editable end-to-end</a:t>
             </a:r>
           </a:p>
         </p:txBody>
@@ -8927,7 +8927,7 @@
                 </a:solidFill>
                 <a:latin typeface="Helvetica Neue"/>
               </a:rPr>
-              <a:t>•  Three-attempt repair loop for typical failure modes</a:t>
+              <a:t>•  Auto-pick chart type from result shape (Vega-Lite spec generation)</a:t>
             </a:r>
           </a:p>
         </p:txBody>
@@ -8962,7 +8962,7 @@
                 </a:solidFill>
                 <a:latin typeface="Helvetica Neue"/>
               </a:rPr>
-              <a:t>•  Land semantic + LLM disambiguation tiers; expand gold-query suite to 50 questions</a:t>
+              <a:t>•  Plain-English answer summary running in parallel with chart render</a:t>
             </a:r>
           </a:p>
         </p:txBody>
@@ -8975,7 +8975,42 @@
         </p:nvSpPr>
         <p:spPr>
           <a:xfrm>
-            <a:off x="640080" y="5001767"/>
+            <a:off x="2286000" y="4919471"/>
+            <a:ext cx="9418320" cy="228600"/>
+          </a:xfrm>
+          <a:prstGeom prst="rect">
+            <a:avLst/>
+          </a:prstGeom>
+          <a:noFill/>
+        </p:spPr>
+        <p:txBody>
+          <a:bodyPr wrap="square" lIns="45720" rIns="45720">
+            <a:spAutoFit/>
+          </a:bodyPr>
+          <a:lstStyle/>
+          <a:p>
+            <a:pPr algn="l"/>
+            <a:r>
+              <a:rPr sz="1000" b="0">
+                <a:solidFill>
+                  <a:srgbClr val="8A95A5"/>
+                </a:solidFill>
+                <a:latin typeface="Helvetica Neue"/>
+              </a:rPr>
+              <a:t>•  Settings page fully editable — pick database, LLM, embedding via UI; ship onboarding flow</a:t>
+            </a:r>
+          </a:p>
+        </p:txBody>
+      </p:sp>
+      <p:sp>
+        <p:nvSpPr>
+          <p:cNvPr id="26" name="TextBox 25"/>
+          <p:cNvSpPr txBox="1"/>
+          <p:nvPr/>
+        </p:nvSpPr>
+        <p:spPr>
+          <a:xfrm>
+            <a:off x="640080" y="5193791"/>
             <a:ext cx="1554480" cy="274320"/>
           </a:xfrm>
           <a:prstGeom prst="rect">
@@ -8997,20 +9032,20 @@
                 </a:solidFill>
                 <a:latin typeface="Helvetica Neue"/>
               </a:rPr>
-              <a:t>Wed May 6</a:t>
-            </a:r>
-          </a:p>
-        </p:txBody>
-      </p:sp>
-      <p:sp>
-        <p:nvSpPr>
-          <p:cNvPr id="26" name="TextBox 25"/>
-          <p:cNvSpPr txBox="1"/>
-          <p:nvPr/>
-        </p:nvSpPr>
-        <p:spPr>
-          <a:xfrm>
-            <a:off x="2286000" y="5001767"/>
+              <a:t>Thu May 7</a:t>
+            </a:r>
+          </a:p>
+        </p:txBody>
+      </p:sp>
+      <p:sp>
+        <p:nvSpPr>
+          <p:cNvPr id="27" name="TextBox 26"/>
+          <p:cNvSpPr txBox="1"/>
+          <p:nvPr/>
+        </p:nvSpPr>
+        <p:spPr>
+          <a:xfrm>
+            <a:off x="2286000" y="5193791"/>
             <a:ext cx="9418320" cy="274320"/>
           </a:xfrm>
           <a:prstGeom prst="rect">
@@ -9032,42 +9067,7 @@
                 </a:solidFill>
                 <a:latin typeface="Helvetica Neue"/>
               </a:rPr>
-              <a:t>Charts, descriptions, Settings UI editable end-to-end</a:t>
-            </a:r>
-          </a:p>
-        </p:txBody>
-      </p:sp>
-      <p:sp>
-        <p:nvSpPr>
-          <p:cNvPr id="27" name="TextBox 26"/>
-          <p:cNvSpPr txBox="1"/>
-          <p:nvPr/>
-        </p:nvSpPr>
-        <p:spPr>
-          <a:xfrm>
-            <a:off x="2286000" y="5193791"/>
-            <a:ext cx="9418320" cy="228600"/>
-          </a:xfrm>
-          <a:prstGeom prst="rect">
-            <a:avLst/>
-          </a:prstGeom>
-          <a:noFill/>
-        </p:spPr>
-        <p:txBody>
-          <a:bodyPr wrap="square" lIns="45720" rIns="45720">
-            <a:spAutoFit/>
-          </a:bodyPr>
-          <a:lstStyle/>
-          <a:p>
-            <a:pPr algn="l"/>
-            <a:r>
-              <a:rPr sz="1000" b="0">
-                <a:solidFill>
-                  <a:srgbClr val="8A95A5"/>
-                </a:solidFill>
-                <a:latin typeface="Helvetica Neue"/>
-              </a:rPr>
-              <a:t>•  Auto-pick chart type from result shape (Vega-Lite spec generation)</a:t>
+              <a:t>Eval dashboard + cluster manager UI + hardening</a:t>
             </a:r>
           </a:p>
         </p:txBody>
@@ -9102,7 +9102,7 @@
                 </a:solidFill>
                 <a:latin typeface="Helvetica Neue"/>
               </a:rPr>
-              <a:t>•  Plain-English answer summary running in parallel with chart render</a:t>
+              <a:t>•  Eval Dashboard page: per-build metrics, regression alerts</a:t>
             </a:r>
           </a:p>
         </p:txBody>
@@ -9137,7 +9137,7 @@
                 </a:solidFill>
                 <a:latin typeface="Helvetica Neue"/>
               </a:rPr>
-              <a:t>•  Settings page fully editable — pick database, LLM, embedding via UI; ship onboarding flow</a:t>
+              <a:t>•  Cluster Manager page: drag tables between groups, trigger rebuild from UI</a:t>
             </a:r>
           </a:p>
         </p:txBody>
@@ -9150,7 +9150,42 @@
         </p:nvSpPr>
         <p:spPr>
           <a:xfrm>
-            <a:off x="640080" y="5852159"/>
+            <a:off x="2286000" y="5769863"/>
+            <a:ext cx="9418320" cy="228600"/>
+          </a:xfrm>
+          <a:prstGeom prst="rect">
+            <a:avLst/>
+          </a:prstGeom>
+          <a:noFill/>
+        </p:spPr>
+        <p:txBody>
+          <a:bodyPr wrap="square" lIns="45720" rIns="45720">
+            <a:spAutoFit/>
+          </a:bodyPr>
+          <a:lstStyle/>
+          <a:p>
+            <a:pPr algn="l"/>
+            <a:r>
+              <a:rPr sz="1000" b="0">
+                <a:solidFill>
+                  <a:srgbClr val="8A95A5"/>
+                </a:solidFill>
+                <a:latin typeface="Helvetica Neue"/>
+              </a:rPr>
+              <a:t>•  Multi-provider matrix; observability dashboards; two security fixes flagged in review</a:t>
+            </a:r>
+          </a:p>
+        </p:txBody>
+      </p:sp>
+      <p:sp>
+        <p:nvSpPr>
+          <p:cNvPr id="31" name="TextBox 30"/>
+          <p:cNvSpPr txBox="1"/>
+          <p:nvPr/>
+        </p:nvSpPr>
+        <p:spPr>
+          <a:xfrm>
+            <a:off x="640080" y="6044183"/>
             <a:ext cx="1554480" cy="274320"/>
           </a:xfrm>
           <a:prstGeom prst="rect">
@@ -9172,20 +9207,20 @@
                 </a:solidFill>
                 <a:latin typeface="Helvetica Neue"/>
               </a:rPr>
-              <a:t>Thu May 7</a:t>
-            </a:r>
-          </a:p>
-        </p:txBody>
-      </p:sp>
-      <p:sp>
-        <p:nvSpPr>
-          <p:cNvPr id="31" name="TextBox 30"/>
-          <p:cNvSpPr txBox="1"/>
-          <p:nvPr/>
-        </p:nvSpPr>
-        <p:spPr>
-          <a:xfrm>
-            <a:off x="2286000" y="5852159"/>
+              <a:t>Fri May 8</a:t>
+            </a:r>
+          </a:p>
+        </p:txBody>
+      </p:sp>
+      <p:sp>
+        <p:nvSpPr>
+          <p:cNvPr id="32" name="TextBox 31"/>
+          <p:cNvSpPr txBox="1"/>
+          <p:nvPr/>
+        </p:nvSpPr>
+        <p:spPr>
+          <a:xfrm>
+            <a:off x="2286000" y="6044183"/>
             <a:ext cx="9418320" cy="274320"/>
           </a:xfrm>
           <a:prstGeom prst="rect">
@@ -9207,42 +9242,7 @@
                 </a:solidFill>
                 <a:latin typeface="Helvetica Neue"/>
               </a:rPr>
-              <a:t>Eval dashboard + cluster manager UI + hardening</a:t>
-            </a:r>
-          </a:p>
-        </p:txBody>
-      </p:sp>
-      <p:sp>
-        <p:nvSpPr>
-          <p:cNvPr id="32" name="TextBox 31"/>
-          <p:cNvSpPr txBox="1"/>
-          <p:nvPr/>
-        </p:nvSpPr>
-        <p:spPr>
-          <a:xfrm>
-            <a:off x="2286000" y="6044183"/>
-            <a:ext cx="9418320" cy="228600"/>
-          </a:xfrm>
-          <a:prstGeom prst="rect">
-            <a:avLst/>
-          </a:prstGeom>
-          <a:noFill/>
-        </p:spPr>
-        <p:txBody>
-          <a:bodyPr wrap="square" lIns="45720" rIns="45720">
-            <a:spAutoFit/>
-          </a:bodyPr>
-          <a:lstStyle/>
-          <a:p>
-            <a:pPr algn="l"/>
-            <a:r>
-              <a:rPr sz="1000" b="0">
-                <a:solidFill>
-                  <a:srgbClr val="8A95A5"/>
-                </a:solidFill>
-                <a:latin typeface="Helvetica Neue"/>
-              </a:rPr>
-              <a:t>•  Eval Dashboard page: per-build metrics, regression alerts</a:t>
+              <a:t>Demo prep + release</a:t>
             </a:r>
           </a:p>
         </p:txBody>
@@ -9277,7 +9277,7 @@
                 </a:solidFill>
                 <a:latin typeface="Helvetica Neue"/>
               </a:rPr>
-              <a:t>•  Cluster Manager page: drag tables between groups, trigger rebuild from UI</a:t>
+              <a:t>•  End-to-end dry-run on a clean Mac and Windows machine</a:t>
             </a:r>
           </a:p>
         </p:txBody>
@@ -9312,7 +9312,7 @@
                 </a:solidFill>
                 <a:latin typeface="Helvetica Neue"/>
               </a:rPr>
-              <a:t>•  Multi-provider matrix; observability dashboards; two security fixes flagged in review</a:t>
+              <a:t>•  Recorded demo: connect DB → ask question → see SQL + rows + chart + summary</a:t>
             </a:r>
           </a:p>
         </p:txBody>
@@ -9325,29 +9325,29 @@
         </p:nvSpPr>
         <p:spPr>
           <a:xfrm>
-            <a:off x="640080" y="6702551"/>
-            <a:ext cx="1554480" cy="274320"/>
-          </a:xfrm>
-          <a:prstGeom prst="rect">
-            <a:avLst/>
-          </a:prstGeom>
-          <a:noFill/>
-        </p:spPr>
-        <p:txBody>
-          <a:bodyPr wrap="square" lIns="45720" rIns="45720">
-            <a:spAutoFit/>
-          </a:bodyPr>
-          <a:lstStyle/>
-          <a:p>
-            <a:pPr algn="l"/>
-            <a:r>
-              <a:rPr sz="1200" b="1">
-                <a:solidFill>
-                  <a:srgbClr val="6EC1FF"/>
-                </a:solidFill>
-                <a:latin typeface="Helvetica Neue"/>
-              </a:rPr>
-              <a:t>Fri May 8</a:t>
+            <a:off x="2286000" y="6620255"/>
+            <a:ext cx="9418320" cy="228600"/>
+          </a:xfrm>
+          <a:prstGeom prst="rect">
+            <a:avLst/>
+          </a:prstGeom>
+          <a:noFill/>
+        </p:spPr>
+        <p:txBody>
+          <a:bodyPr wrap="square" lIns="45720" rIns="45720">
+            <a:spAutoFit/>
+          </a:bodyPr>
+          <a:lstStyle/>
+          <a:p>
+            <a:pPr algn="l"/>
+            <a:r>
+              <a:rPr sz="1000" b="0">
+                <a:solidFill>
+                  <a:srgbClr val="8A95A5"/>
+                </a:solidFill>
+                <a:latin typeface="Helvetica Neue"/>
+              </a:rPr>
+              <a:t>•  v0.8 release tag + operator runbook + provider-swap guide</a:t>
             </a:r>
           </a:p>
         </p:txBody>
@@ -9355,146 +9355,6 @@
       <p:sp>
         <p:nvSpPr>
           <p:cNvPr id="36" name="TextBox 35"/>
-          <p:cNvSpPr txBox="1"/>
-          <p:nvPr/>
-        </p:nvSpPr>
-        <p:spPr>
-          <a:xfrm>
-            <a:off x="2286000" y="6702551"/>
-            <a:ext cx="9418320" cy="274320"/>
-          </a:xfrm>
-          <a:prstGeom prst="rect">
-            <a:avLst/>
-          </a:prstGeom>
-          <a:noFill/>
-        </p:spPr>
-        <p:txBody>
-          <a:bodyPr wrap="square" lIns="45720" rIns="45720">
-            <a:spAutoFit/>
-          </a:bodyPr>
-          <a:lstStyle/>
-          <a:p>
-            <a:pPr algn="l"/>
-            <a:r>
-              <a:rPr sz="1200" b="1">
-                <a:solidFill>
-                  <a:srgbClr val="E6EAF0"/>
-                </a:solidFill>
-                <a:latin typeface="Helvetica Neue"/>
-              </a:rPr>
-              <a:t>Demo prep + release</a:t>
-            </a:r>
-          </a:p>
-        </p:txBody>
-      </p:sp>
-      <p:sp>
-        <p:nvSpPr>
-          <p:cNvPr id="37" name="TextBox 36"/>
-          <p:cNvSpPr txBox="1"/>
-          <p:nvPr/>
-        </p:nvSpPr>
-        <p:spPr>
-          <a:xfrm>
-            <a:off x="2286000" y="6894575"/>
-            <a:ext cx="9418320" cy="228600"/>
-          </a:xfrm>
-          <a:prstGeom prst="rect">
-            <a:avLst/>
-          </a:prstGeom>
-          <a:noFill/>
-        </p:spPr>
-        <p:txBody>
-          <a:bodyPr wrap="square" lIns="45720" rIns="45720">
-            <a:spAutoFit/>
-          </a:bodyPr>
-          <a:lstStyle/>
-          <a:p>
-            <a:pPr algn="l"/>
-            <a:r>
-              <a:rPr sz="1000" b="0">
-                <a:solidFill>
-                  <a:srgbClr val="8A95A5"/>
-                </a:solidFill>
-                <a:latin typeface="Helvetica Neue"/>
-              </a:rPr>
-              <a:t>•  End-to-end dry-run on a clean Mac and Windows machine</a:t>
-            </a:r>
-          </a:p>
-        </p:txBody>
-      </p:sp>
-      <p:sp>
-        <p:nvSpPr>
-          <p:cNvPr id="38" name="TextBox 37"/>
-          <p:cNvSpPr txBox="1"/>
-          <p:nvPr/>
-        </p:nvSpPr>
-        <p:spPr>
-          <a:xfrm>
-            <a:off x="2286000" y="7086599"/>
-            <a:ext cx="9418320" cy="228600"/>
-          </a:xfrm>
-          <a:prstGeom prst="rect">
-            <a:avLst/>
-          </a:prstGeom>
-          <a:noFill/>
-        </p:spPr>
-        <p:txBody>
-          <a:bodyPr wrap="square" lIns="45720" rIns="45720">
-            <a:spAutoFit/>
-          </a:bodyPr>
-          <a:lstStyle/>
-          <a:p>
-            <a:pPr algn="l"/>
-            <a:r>
-              <a:rPr sz="1000" b="0">
-                <a:solidFill>
-                  <a:srgbClr val="8A95A5"/>
-                </a:solidFill>
-                <a:latin typeface="Helvetica Neue"/>
-              </a:rPr>
-              <a:t>•  Recorded demo: connect DB → ask question → see SQL + rows + chart + summary</a:t>
-            </a:r>
-          </a:p>
-        </p:txBody>
-      </p:sp>
-      <p:sp>
-        <p:nvSpPr>
-          <p:cNvPr id="39" name="TextBox 38"/>
-          <p:cNvSpPr txBox="1"/>
-          <p:nvPr/>
-        </p:nvSpPr>
-        <p:spPr>
-          <a:xfrm>
-            <a:off x="2286000" y="7278623"/>
-            <a:ext cx="9418320" cy="228600"/>
-          </a:xfrm>
-          <a:prstGeom prst="rect">
-            <a:avLst/>
-          </a:prstGeom>
-          <a:noFill/>
-        </p:spPr>
-        <p:txBody>
-          <a:bodyPr wrap="square" lIns="45720" rIns="45720">
-            <a:spAutoFit/>
-          </a:bodyPr>
-          <a:lstStyle/>
-          <a:p>
-            <a:pPr algn="l"/>
-            <a:r>
-              <a:rPr sz="1000" b="0">
-                <a:solidFill>
-                  <a:srgbClr val="8A95A5"/>
-                </a:solidFill>
-                <a:latin typeface="Helvetica Neue"/>
-              </a:rPr>
-              <a:t>•  v0.8 release tag + operator runbook + provider-swap guide</a:t>
-            </a:r>
-          </a:p>
-        </p:txBody>
-      </p:sp>
-      <p:sp>
-        <p:nvSpPr>
-          <p:cNvPr id="40" name="TextBox 39"/>
           <p:cNvSpPr txBox="1"/>
           <p:nvPr/>
         </p:nvSpPr>
@@ -9529,7 +9389,7 @@
       </p:sp>
       <p:sp>
         <p:nvSpPr>
-          <p:cNvPr id="41" name="TextBox 40"/>
+          <p:cNvPr id="37" name="TextBox 36"/>
           <p:cNvSpPr txBox="1"/>
           <p:nvPr/>
         </p:nvSpPr>
@@ -11188,7 +11048,7 @@
                 </a:solidFill>
                 <a:latin typeface="Helvetica Neue"/>
               </a:rPr>
-              <a:t>Cluster-creation is the only complete workstream today; everything else is in progress for the 7-day push to demo</a:t>
+              <a:t>Cluster-creation is the only complete workstream today; everything else is in progress for the 6-day push to demo</a:t>
             </a:r>
           </a:p>
         </p:txBody>
@@ -12488,7 +12348,7 @@
                 </a:solidFill>
                 <a:latin typeface="Helvetica Neue"/>
               </a:rPr>
-              <a:t>1 of 8 complete · 7 working days to demo</a:t>
+              <a:t>1 of 8 complete · 6 working days to demo</a:t>
             </a:r>
           </a:p>
         </p:txBody>
@@ -13455,7 +13315,7 @@
                 </a:solidFill>
                 <a:latin typeface="Helvetica Neue"/>
               </a:rPr>
-              <a:t>Green = complete today  ·  Amber = in progress, targeted for the 7-day push</a:t>
+              <a:t>Green = complete today  ·  Amber = in progress, targeted for the 6-day push</a:t>
             </a:r>
           </a:p>
         </p:txBody>

</xml_diff>